<commit_message>
Added slides from top consulting firms
</commit_message>
<xml_diff>
--- a/output.pptx
+++ b/output.pptx
@@ -1121,13 +1121,6 @@
 <file path=ppt/slides/slide1.xml><?xml version="1.0" encoding="utf-8"?>
 <p:sld xmlns:a="http://schemas.openxmlformats.org/drawingml/2006/main" xmlns:r="http://schemas.openxmlformats.org/officeDocument/2006/relationships" xmlns:p="http://schemas.openxmlformats.org/presentationml/2006/main">
   <p:cSld name="Slide 1">
-    <p:bg>
-      <p:bgPr>
-        <a:solidFill>
-          <a:srgbClr val="1E2761"/>
-        </a:solidFill>
-      </p:bgPr>
-    </p:bg>
     <p:spTree>
       <p:nvGrpSpPr>
         <p:cNvPr id="1" name=""/>
@@ -1151,7 +1144,7 @@
         <p:spPr>
           <a:xfrm>
             <a:off x="457200" y="457200"/>
-            <a:ext cx="8229600" cy="548640"/>
+            <a:ext cx="8229600" cy="914400"/>
           </a:xfrm>
           <a:prstGeom prst="rect">
             <a:avLst/>
@@ -1163,13 +1156,13 @@
           <a:bodyPr wrap="square" rtlCol="0" anchor="ctr"/>
           <a:lstStyle/>
           <a:p>
-            <a:pPr indent="0" marL="0">
+            <a:pPr algn="ctr" indent="0" marL="0">
               <a:buNone/>
             </a:pPr>
             <a:r>
               <a:rPr lang="en-US" sz="3600" b="1" dirty="0">
                 <a:solidFill>
-                  <a:srgbClr val="FFFFFF"/>
+                  <a:srgbClr val="2C5F2D"/>
                 </a:solidFill>
                 <a:latin typeface="Georgia" pitchFamily="34" charset="0"/>
                 <a:ea typeface="Georgia" pitchFamily="34" charset="-122"/>
@@ -1189,7 +1182,7 @@
         </p:nvSpPr>
         <p:spPr>
           <a:xfrm>
-            <a:off x="457200" y="1097280"/>
+            <a:off x="457200" y="1828800"/>
             <a:ext cx="8229600" cy="2743200"/>
           </a:xfrm>
           <a:prstGeom prst="rect">
@@ -1199,58 +1192,58 @@
           <a:ln/>
         </p:spPr>
         <p:txBody>
-          <a:bodyPr wrap="square" rtlCol="0" anchor="ctr"/>
+          <a:bodyPr wrap="square" rtlCol="0" anchor="t"/>
           <a:lstStyle/>
           <a:p>
-            <a:pPr indent="0" marL="0">
+            <a:pPr algn="l" indent="0" marL="0">
               <a:buNone/>
             </a:pPr>
             <a:r>
-              <a:rPr lang="en-US" sz="1600" dirty="0">
+              <a:rPr lang="en-US" sz="1800" dirty="0">
                 <a:solidFill>
-                  <a:srgbClr val="FFFFFF"/>
+                  <a:srgbClr val="97BC62"/>
                 </a:solidFill>
                 <a:latin typeface="Calibri" pitchFamily="34" charset="0"/>
                 <a:ea typeface="Calibri" pitchFamily="34" charset="-122"/>
                 <a:cs typeface="Calibri" pitchFamily="34" charset="-120"/>
               </a:rPr>
-              <a:t>Effective data project management is crucial in today's data-driven world, as it enables organizations to make informed decisions, drive business growth, and stay competitive. An overview of data project management involves understanding the entire lifecycle of a data project, from initiation to deployment, and ensuring that all stakeholders are aligned and working towards a common goal.</a:t>
-            </a:r>
-            <a:endParaRPr lang="en-US" sz="1600" dirty="0"/>
-          </a:p>
-          <a:p>
-            <a:pPr indent="0" marL="0">
+              <a:t>Effective data project management is crucial for organizations to derive actionable insights and make informed decisions, as it enables the efficient collection, analysis, and interpretation of complex data sets.</a:t>
+            </a:r>
+            <a:endParaRPr lang="en-US" sz="1800" dirty="0"/>
+          </a:p>
+          <a:p>
+            <a:pPr algn="l" indent="0" marL="0">
               <a:buNone/>
             </a:pPr>
             <a:r>
-              <a:rPr lang="en-US" sz="1600" dirty="0">
+              <a:rPr lang="en-US" sz="1800" dirty="0">
                 <a:solidFill>
-                  <a:srgbClr val="FFFFFF"/>
+                  <a:srgbClr val="97BC62"/>
                 </a:solidFill>
                 <a:latin typeface="Calibri" pitchFamily="34" charset="0"/>
                 <a:ea typeface="Calibri" pitchFamily="34" charset="-122"/>
                 <a:cs typeface="Calibri" pitchFamily="34" charset="-120"/>
               </a:rPr>
-              <a:t>The importance of data project management cannot be overstated, as it helps to mitigate risks, ensure timely completion, and guarantee that the project meets its intended objectives. By prioritizing data project management, organizations can unlock the full potential of their data assets and drive meaningful business outcomes.</a:t>
-            </a:r>
-            <a:endParaRPr lang="en-US" sz="1600" dirty="0"/>
-          </a:p>
-          <a:p>
-            <a:pPr indent="0" marL="0">
+              <a:t>A well-managed data project ensures that all stakeholders are aligned with the project's objectives, timelines, and resources, ultimately leading to successful project delivery and maximum ROI.</a:t>
+            </a:r>
+            <a:endParaRPr lang="en-US" sz="1800" dirty="0"/>
+          </a:p>
+          <a:p>
+            <a:pPr algn="l" indent="0" marL="0">
               <a:buNone/>
             </a:pPr>
             <a:r>
-              <a:rPr lang="en-US" sz="1600" dirty="0">
+              <a:rPr lang="en-US" sz="1800" dirty="0">
                 <a:solidFill>
-                  <a:srgbClr val="FFFFFF"/>
+                  <a:srgbClr val="97BC62"/>
                 </a:solidFill>
                 <a:latin typeface="Calibri" pitchFamily="34" charset="0"/>
                 <a:ea typeface="Calibri" pitchFamily="34" charset="-122"/>
                 <a:cs typeface="Calibri" pitchFamily="34" charset="-120"/>
               </a:rPr>
-              <a:t>A well-managed data project requires a deep understanding of the organization's data ecosystem, including its strengths, weaknesses, and areas for improvement. By taking a holistic approach to data project management, organizations can identify opportunities for innovation, optimize their data workflows, and create a culture of data-driven decision-making.</a:t>
-            </a:r>
-            <a:endParaRPr lang="en-US" sz="1600" dirty="0"/>
+              <a:t>By adopting a structured approach to data project management, organizations can mitigate potential risks, ensure data quality and integrity, and foster a culture of data-driven decision-making.</a:t>
+            </a:r>
+            <a:endParaRPr lang="en-US" sz="1800" dirty="0"/>
           </a:p>
         </p:txBody>
       </p:sp>
@@ -1265,13 +1258,6 @@
 <file path=ppt/slides/slide2.xml><?xml version="1.0" encoding="utf-8"?>
 <p:sld xmlns:a="http://schemas.openxmlformats.org/drawingml/2006/main" xmlns:r="http://schemas.openxmlformats.org/officeDocument/2006/relationships" xmlns:p="http://schemas.openxmlformats.org/presentationml/2006/main">
   <p:cSld name="Slide 2">
-    <p:bg>
-      <p:bgPr>
-        <a:solidFill>
-          <a:srgbClr val="1E2761"/>
-        </a:solidFill>
-      </p:bgPr>
-    </p:bg>
     <p:spTree>
       <p:nvGrpSpPr>
         <p:cNvPr id="1" name=""/>
@@ -1295,7 +1281,7 @@
         <p:spPr>
           <a:xfrm>
             <a:off x="457200" y="457200"/>
-            <a:ext cx="8229600" cy="548640"/>
+            <a:ext cx="8229600" cy="914400"/>
           </a:xfrm>
           <a:prstGeom prst="rect">
             <a:avLst/>
@@ -1307,13 +1293,13 @@
           <a:bodyPr wrap="square" rtlCol="0" anchor="ctr"/>
           <a:lstStyle/>
           <a:p>
-            <a:pPr indent="0" marL="0">
+            <a:pPr algn="ctr" indent="0" marL="0">
               <a:buNone/>
             </a:pPr>
             <a:r>
               <a:rPr lang="en-US" sz="3600" b="1" dirty="0">
                 <a:solidFill>
-                  <a:srgbClr val="FFFFFF"/>
+                  <a:srgbClr val="2C5F2D"/>
                 </a:solidFill>
                 <a:latin typeface="Georgia" pitchFamily="34" charset="0"/>
                 <a:ea typeface="Georgia" pitchFamily="34" charset="-122"/>
@@ -1333,7 +1319,7 @@
         </p:nvSpPr>
         <p:spPr>
           <a:xfrm>
-            <a:off x="457200" y="1097280"/>
+            <a:off x="457200" y="1828800"/>
             <a:ext cx="8229600" cy="2743200"/>
           </a:xfrm>
           <a:prstGeom prst="rect">
@@ -1343,58 +1329,58 @@
           <a:ln/>
         </p:spPr>
         <p:txBody>
-          <a:bodyPr wrap="square" rtlCol="0" anchor="ctr"/>
+          <a:bodyPr wrap="square" rtlCol="0" anchor="t"/>
           <a:lstStyle/>
           <a:p>
-            <a:pPr indent="0" marL="0">
+            <a:pPr algn="l" indent="0" marL="0">
               <a:buNone/>
             </a:pPr>
             <a:r>
-              <a:rPr lang="en-US" sz="1600" dirty="0">
+              <a:rPr lang="en-US" sz="1800" dirty="0">
                 <a:solidFill>
-                  <a:srgbClr val="FFFFFF"/>
+                  <a:srgbClr val="97BC62"/>
                 </a:solidFill>
                 <a:latin typeface="Calibri" pitchFamily="34" charset="0"/>
                 <a:ea typeface="Calibri" pitchFamily="34" charset="-122"/>
                 <a:cs typeface="Calibri" pitchFamily="34" charset="-120"/>
               </a:rPr>
-              <a:t>Define clear and measurable objectives that align with the organization's overall strategy, ensuring all stakeholders are aware of the project's purpose and expected outcomes.</a:t>
-            </a:r>
-            <a:endParaRPr lang="en-US" sz="1600" dirty="0"/>
-          </a:p>
-          <a:p>
-            <a:pPr indent="0" marL="0">
+              <a:t>Define clear and measurable objectives that align with the organization's overall strategy, ensuring everyone involved in the project is working towards the same goals.</a:t>
+            </a:r>
+            <a:endParaRPr lang="en-US" sz="1800" dirty="0"/>
+          </a:p>
+          <a:p>
+            <a:pPr algn="l" indent="0" marL="0">
               <a:buNone/>
             </a:pPr>
             <a:r>
-              <a:rPr lang="en-US" sz="1600" dirty="0">
+              <a:rPr lang="en-US" sz="1800" dirty="0">
                 <a:solidFill>
-                  <a:srgbClr val="FFFFFF"/>
+                  <a:srgbClr val="97BC62"/>
                 </a:solidFill>
                 <a:latin typeface="Calibri" pitchFamily="34" charset="0"/>
                 <a:ea typeface="Calibri" pitchFamily="34" charset="-122"/>
                 <a:cs typeface="Calibri" pitchFamily="34" charset="-120"/>
               </a:rPr>
-              <a:t>Identify and engage with key stakeholders, including project sponsors, team members, and end-users, to understand their needs, expectations, and potential concerns.</a:t>
-            </a:r>
-            <a:endParaRPr lang="en-US" sz="1600" dirty="0"/>
-          </a:p>
-          <a:p>
-            <a:pPr indent="0" marL="0">
+              <a:t>Identify all relevant stakeholders, including project team members, sponsors, customers, and end-users, to ensure their needs and expectations are considered and managed throughout the project.</a:t>
+            </a:r>
+            <a:endParaRPr lang="en-US" sz="1800" dirty="0"/>
+          </a:p>
+          <a:p>
+            <a:pPr algn="l" indent="0" marL="0">
               <a:buNone/>
             </a:pPr>
             <a:r>
-              <a:rPr lang="en-US" sz="1600" dirty="0">
+              <a:rPr lang="en-US" sz="1800" dirty="0">
                 <a:solidFill>
-                  <a:srgbClr val="FFFFFF"/>
+                  <a:srgbClr val="97BC62"/>
                 </a:solidFill>
                 <a:latin typeface="Calibri" pitchFamily="34" charset="0"/>
                 <a:ea typeface="Calibri" pitchFamily="34" charset="-122"/>
                 <a:cs typeface="Calibri" pitchFamily="34" charset="-120"/>
               </a:rPr>
-              <a:t>Create a detailed project timeline, including milestones and deadlines, to help track progress, allocate resources, and make informed decisions throughout the project lifecycle.</a:t>
-            </a:r>
-            <a:endParaRPr lang="en-US" sz="1600" dirty="0"/>
+              <a:t>Create a detailed project timeline, including milestones and deadlines, to help track progress, allocate resources, and make adjustments as needed.</a:t>
+            </a:r>
+            <a:endParaRPr lang="en-US" sz="1800" dirty="0"/>
           </a:p>
         </p:txBody>
       </p:sp>
@@ -1409,13 +1395,6 @@
 <file path=ppt/slides/slide3.xml><?xml version="1.0" encoding="utf-8"?>
 <p:sld xmlns:a="http://schemas.openxmlformats.org/drawingml/2006/main" xmlns:r="http://schemas.openxmlformats.org/officeDocument/2006/relationships" xmlns:p="http://schemas.openxmlformats.org/presentationml/2006/main">
   <p:cSld name="Slide 3">
-    <p:bg>
-      <p:bgPr>
-        <a:solidFill>
-          <a:srgbClr val="1E2761"/>
-        </a:solidFill>
-      </p:bgPr>
-    </p:bg>
     <p:spTree>
       <p:nvGrpSpPr>
         <p:cNvPr id="1" name=""/>
@@ -1439,7 +1418,7 @@
         <p:spPr>
           <a:xfrm>
             <a:off x="457200" y="457200"/>
-            <a:ext cx="8229600" cy="548640"/>
+            <a:ext cx="8229600" cy="914400"/>
           </a:xfrm>
           <a:prstGeom prst="rect">
             <a:avLst/>
@@ -1451,13 +1430,13 @@
           <a:bodyPr wrap="square" rtlCol="0" anchor="ctr"/>
           <a:lstStyle/>
           <a:p>
-            <a:pPr indent="0" marL="0">
+            <a:pPr algn="ctr" indent="0" marL="0">
               <a:buNone/>
             </a:pPr>
             <a:r>
               <a:rPr lang="en-US" sz="3600" b="1" dirty="0">
                 <a:solidFill>
-                  <a:srgbClr val="FFFFFF"/>
+                  <a:srgbClr val="2C5F2D"/>
                 </a:solidFill>
                 <a:latin typeface="Georgia" pitchFamily="34" charset="0"/>
                 <a:ea typeface="Georgia" pitchFamily="34" charset="-122"/>
@@ -1477,7 +1456,7 @@
         </p:nvSpPr>
         <p:spPr>
           <a:xfrm>
-            <a:off x="457200" y="1097280"/>
+            <a:off x="457200" y="1828800"/>
             <a:ext cx="8229600" cy="2743200"/>
           </a:xfrm>
           <a:prstGeom prst="rect">
@@ -1487,58 +1466,58 @@
           <a:ln/>
         </p:spPr>
         <p:txBody>
-          <a:bodyPr wrap="square" rtlCol="0" anchor="ctr"/>
+          <a:bodyPr wrap="square" rtlCol="0" anchor="t"/>
           <a:lstStyle/>
           <a:p>
-            <a:pPr indent="0" marL="0">
+            <a:pPr algn="l" indent="0" marL="0">
               <a:buNone/>
             </a:pPr>
             <a:r>
-              <a:rPr lang="en-US" sz="1600" dirty="0">
+              <a:rPr lang="en-US" sz="1800" dirty="0">
                 <a:solidFill>
-                  <a:srgbClr val="FFFFFF"/>
+                  <a:srgbClr val="97BC62"/>
                 </a:solidFill>
                 <a:latin typeface="Calibri" pitchFamily="34" charset="0"/>
                 <a:ea typeface="Calibri" pitchFamily="34" charset="-122"/>
                 <a:cs typeface="Calibri" pitchFamily="34" charset="-120"/>
               </a:rPr>
-              <a:t>Data collection is the process of gathering and measuring data from various sources, which can include databases, files, and external data providers. It is essential to ensure that the data collected is relevant, accurate, and in the correct format for analysis.</a:t>
-            </a:r>
-            <a:endParaRPr lang="en-US" sz="1600" dirty="0"/>
-          </a:p>
-          <a:p>
-            <a:pPr indent="0" marL="0">
+              <a:t>Data Collection: This involves gathering data from various sources, including databases, files, and user input, to create a comprehensive dataset for analysis. It requires careful planning to ensure that the data is accurate, complete, and relevant to the project goals.</a:t>
+            </a:r>
+            <a:endParaRPr lang="en-US" sz="1800" dirty="0"/>
+          </a:p>
+          <a:p>
+            <a:pPr algn="l" indent="0" marL="0">
               <a:buNone/>
             </a:pPr>
             <a:r>
-              <a:rPr lang="en-US" sz="1600" dirty="0">
+              <a:rPr lang="en-US" sz="1800" dirty="0">
                 <a:solidFill>
-                  <a:srgbClr val="FFFFFF"/>
+                  <a:srgbClr val="97BC62"/>
                 </a:solidFill>
                 <a:latin typeface="Calibri" pitchFamily="34" charset="0"/>
                 <a:ea typeface="Calibri" pitchFamily="34" charset="-122"/>
                 <a:cs typeface="Calibri" pitchFamily="34" charset="-120"/>
               </a:rPr>
-              <a:t>Data cleaning involves identifying and correcting errors, inconsistencies, and inaccuracies in the collected data to ensure that it is reliable and usable for analysis. This step is critical in maintaining data quality and preventing incorrect insights.</a:t>
-            </a:r>
-            <a:endParaRPr lang="en-US" sz="1600" dirty="0"/>
-          </a:p>
-          <a:p>
-            <a:pPr indent="0" marL="0">
+              <a:t>Data Cleaning: Once the data is collected, it needs to be cleaned to remove any errors, inconsistencies, or duplicates. This step is crucial in ensuring that the data is reliable and can be used for meaningful analysis.</a:t>
+            </a:r>
+            <a:endParaRPr lang="en-US" sz="1800" dirty="0"/>
+          </a:p>
+          <a:p>
+            <a:pPr algn="l" indent="0" marL="0">
               <a:buNone/>
             </a:pPr>
             <a:r>
-              <a:rPr lang="en-US" sz="1600" dirty="0">
+              <a:rPr lang="en-US" sz="1800" dirty="0">
                 <a:solidFill>
-                  <a:srgbClr val="FFFFFF"/>
+                  <a:srgbClr val="97BC62"/>
                 </a:solidFill>
                 <a:latin typeface="Calibri" pitchFamily="34" charset="0"/>
                 <a:ea typeface="Calibri" pitchFamily="34" charset="-122"/>
                 <a:cs typeface="Calibri" pitchFamily="34" charset="-120"/>
               </a:rPr>
-              <a:t>Data analysis is the process of examining and interpreting the cleaned data to extract insights, patterns, and relationships. It involves using various statistical and analytical techniques to turn data into actionable information that can inform business decisions.</a:t>
-            </a:r>
-            <a:endParaRPr lang="en-US" sz="1600" dirty="0"/>
+              <a:t>Data Analysis: After the data is cleaned, it can be analyzed to extract insights and patterns. This involves using statistical techniques, data visualization tools, and machine learning algorithms to identify trends, correlations, and relationships within the data.</a:t>
+            </a:r>
+            <a:endParaRPr lang="en-US" sz="1800" dirty="0"/>
           </a:p>
         </p:txBody>
       </p:sp>
@@ -1553,13 +1532,6 @@
 <file path=ppt/slides/slide4.xml><?xml version="1.0" encoding="utf-8"?>
 <p:sld xmlns:a="http://schemas.openxmlformats.org/drawingml/2006/main" xmlns:r="http://schemas.openxmlformats.org/officeDocument/2006/relationships" xmlns:p="http://schemas.openxmlformats.org/presentationml/2006/main">
   <p:cSld name="Slide 4">
-    <p:bg>
-      <p:bgPr>
-        <a:solidFill>
-          <a:srgbClr val="1E2761"/>
-        </a:solidFill>
-      </p:bgPr>
-    </p:bg>
     <p:spTree>
       <p:nvGrpSpPr>
         <p:cNvPr id="1" name=""/>
@@ -1583,7 +1555,7 @@
         <p:spPr>
           <a:xfrm>
             <a:off x="457200" y="457200"/>
-            <a:ext cx="8229600" cy="548640"/>
+            <a:ext cx="8229600" cy="914400"/>
           </a:xfrm>
           <a:prstGeom prst="rect">
             <a:avLst/>
@@ -1595,13 +1567,13 @@
           <a:bodyPr wrap="square" rtlCol="0" anchor="ctr"/>
           <a:lstStyle/>
           <a:p>
-            <a:pPr indent="0" marL="0">
+            <a:pPr algn="ctr" indent="0" marL="0">
               <a:buNone/>
             </a:pPr>
             <a:r>
               <a:rPr lang="en-US" sz="3600" b="1" dirty="0">
                 <a:solidFill>
-                  <a:srgbClr val="FFFFFF"/>
+                  <a:srgbClr val="2C5F2D"/>
                 </a:solidFill>
                 <a:latin typeface="Georgia" pitchFamily="34" charset="0"/>
                 <a:ea typeface="Georgia" pitchFamily="34" charset="-122"/>
@@ -1621,7 +1593,7 @@
         </p:nvSpPr>
         <p:spPr>
           <a:xfrm>
-            <a:off x="457200" y="1097280"/>
+            <a:off x="457200" y="1828800"/>
             <a:ext cx="8229600" cy="2743200"/>
           </a:xfrm>
           <a:prstGeom prst="rect">
@@ -1631,58 +1603,58 @@
           <a:ln/>
         </p:spPr>
         <p:txBody>
-          <a:bodyPr wrap="square" rtlCol="0" anchor="ctr"/>
+          <a:bodyPr wrap="square" rtlCol="0" anchor="t"/>
           <a:lstStyle/>
           <a:p>
-            <a:pPr indent="0" marL="0">
+            <a:pPr algn="l" indent="0" marL="0">
               <a:buNone/>
             </a:pPr>
             <a:r>
-              <a:rPr lang="en-US" sz="1600" dirty="0">
+              <a:rPr lang="en-US" sz="1800" dirty="0">
                 <a:solidFill>
-                  <a:srgbClr val="FFFFFF"/>
+                  <a:srgbClr val="97BC62"/>
                 </a:solidFill>
                 <a:latin typeface="Calibri" pitchFamily="34" charset="0"/>
                 <a:ea typeface="Calibri" pitchFamily="34" charset="-122"/>
                 <a:cs typeface="Calibri" pitchFamily="34" charset="-120"/>
               </a:rPr>
-              <a:t>To ensure the success of a data project, it's essential to follow best practices, including establishing clear goals and objectives, selecting the right tools and technologies, and fostering a culture of collaboration and open communication among team members.</a:t>
-            </a:r>
-            <a:endParaRPr lang="en-US" sz="1600" dirty="0"/>
-          </a:p>
-          <a:p>
-            <a:pPr indent="0" marL="0">
+              <a:t>To ensure the success and longevity of a data project, it's essential to implement best practices such as continuous monitoring, regular updates, and thorough documentation. This not only helps in maintaining the project's integrity but also facilitates knowledge sharing among team members.</a:t>
+            </a:r>
+            <a:endParaRPr lang="en-US" sz="1800" dirty="0"/>
+          </a:p>
+          <a:p>
+            <a:pPr algn="l" indent="0" marL="0">
               <a:buNone/>
             </a:pPr>
             <a:r>
-              <a:rPr lang="en-US" sz="1600" dirty="0">
+              <a:rPr lang="en-US" sz="1800" dirty="0">
                 <a:solidFill>
-                  <a:srgbClr val="FFFFFF"/>
+                  <a:srgbClr val="97BC62"/>
                 </a:solidFill>
                 <a:latin typeface="Calibri" pitchFamily="34" charset="0"/>
                 <a:ea typeface="Calibri" pitchFamily="34" charset="-122"/>
                 <a:cs typeface="Calibri" pitchFamily="34" charset="-120"/>
               </a:rPr>
-              <a:t>By adopting these best practices, organizations can unlock the full potential of their data, drive business growth, and stay ahead of the competition in an increasingly data-driven world.</a:t>
-            </a:r>
-            <a:endParaRPr lang="en-US" sz="1600" dirty="0"/>
-          </a:p>
-          <a:p>
-            <a:pPr indent="0" marL="0">
+              <a:t>Embracing future directions in data management, such as the integration of artificial intelligence and machine learning, can significantly enhance the project's capabilities and provide more insightful outcomes. Staying updated with the latest trends and technologies is crucial for adapting to changing project requirements.</a:t>
+            </a:r>
+            <a:endParaRPr lang="en-US" sz="1800" dirty="0"/>
+          </a:p>
+          <a:p>
+            <a:pPr algn="l" indent="0" marL="0">
               <a:buNone/>
             </a:pPr>
             <a:r>
-              <a:rPr lang="en-US" sz="1600" dirty="0">
+              <a:rPr lang="en-US" sz="1800" dirty="0">
                 <a:solidFill>
-                  <a:srgbClr val="FFFFFF"/>
+                  <a:srgbClr val="97BC62"/>
                 </a:solidFill>
                 <a:latin typeface="Calibri" pitchFamily="34" charset="0"/>
                 <a:ea typeface="Calibri" pitchFamily="34" charset="-122"/>
                 <a:cs typeface="Calibri" pitchFamily="34" charset="-120"/>
               </a:rPr>
-              <a:t>As the field of data science continues to evolve, future directions for data projects may include the integration of emerging technologies like artificial intelligence and machine learning, the development of more sophisticated data visualization tools, and the exploration of new applications for data analytics in various industries.</a:t>
-            </a:r>
-            <a:endParaRPr lang="en-US" sz="1600" dirty="0"/>
+              <a:t>By combining best practices with a forward-thinking approach, data project managers can create a robust and adaptable framework that supports the project's goals and objectives, while also being responsive to emerging challenges and opportunities.</a:t>
+            </a:r>
+            <a:endParaRPr lang="en-US" sz="1800" dirty="0"/>
           </a:p>
         </p:txBody>
       </p:sp>

</xml_diff>